<commit_message>
CRV Q29: standalone PCL deployment-frequency distribution (Q24 Stmt1 touch-count definition, marginal histogram); remove superseded channel-frequency file
Co-Authored-By: Claude Fable 5 <noreply@anthropic.com>
</commit_message>
<xml_diff>
--- a/campaigns/CRV/Presentation1.pptx
+++ b/campaigns/CRV/Presentation1.pptx
@@ -11,6 +11,8 @@
     <p:sldId id="270" r:id="rId5"/>
     <p:sldId id="271" r:id="rId6"/>
     <p:sldId id="274" r:id="rId7"/>
+    <p:sldId id="277" r:id="rId8"/>
+    <p:sldId id="280" r:id="rId9"/>
   </p:sldIdLst>
   <p:sldSz cx="12192000" cy="6858000"/>
   <p:notesSz cx="6858000" cy="9144000"/>
@@ -3565,7 +3567,7 @@
 
 <file path=ppt/charts/chart7.xml><?xml version="1.0" encoding="utf-8"?>
 <c:chartSpace xmlns:c="http://schemas.openxmlformats.org/drawingml/2006/chart" xmlns:a="http://schemas.openxmlformats.org/drawingml/2006/main" xmlns:r="http://schemas.openxmlformats.org/officeDocument/2006/relationships" xmlns:c16r2="http://schemas.microsoft.com/office/drawing/2015/06/chart">
-  <c:date1904 val="1"/>
+  <c:date1904 val="0"/>
   <c:lang val="en-US"/>
   <c:roundedCorners val="1"/>
   <c:style val="2"/>
@@ -3633,7 +3635,15 @@
           <c:idx val="0"/>
           <c:order val="0"/>
           <c:tx>
-            <c:v>_baseline</c:v>
+            <c:strRef>
+              <c:f>Sheet1!$B$1</c:f>
+              <c:strCache>
+                <c:ptCount val="1"/>
+                <c:pt idx="0">
+                  <c:v>_baseline</c:v>
+                </c:pt>
+              </c:strCache>
+            </c:strRef>
           </c:tx>
           <c:spPr>
             <a:noFill/>
@@ -3642,129 +3652,136 @@
             </a:ln>
           </c:spPr>
           <c:cat>
-            <c:strLit>
-              <c:ptCount val="19"/>
-              <c:pt idx="0">
-                <c:v>Oct 24</c:v>
-              </c:pt>
-              <c:pt idx="1">
-                <c:v>Nov 24</c:v>
-              </c:pt>
-              <c:pt idx="2">
-                <c:v>Dec 24</c:v>
-              </c:pt>
-              <c:pt idx="3">
-                <c:v>Jan 25</c:v>
-              </c:pt>
-              <c:pt idx="4">
-                <c:v>Feb 25</c:v>
-              </c:pt>
-              <c:pt idx="5">
-                <c:v>Mar 25</c:v>
-              </c:pt>
-              <c:pt idx="6">
-                <c:v>Apr 25</c:v>
-              </c:pt>
-              <c:pt idx="7">
-                <c:v>May 25</c:v>
-              </c:pt>
-              <c:pt idx="8">
-                <c:v>Jun 25</c:v>
-              </c:pt>
-              <c:pt idx="9">
-                <c:v>Jul 25</c:v>
-              </c:pt>
-              <c:pt idx="10">
-                <c:v>Aug 25</c:v>
-              </c:pt>
-              <c:pt idx="11">
-                <c:v>Sep 25</c:v>
-              </c:pt>
-              <c:pt idx="12">
-                <c:v>Oct 25</c:v>
-              </c:pt>
-              <c:pt idx="13">
-                <c:v>Nov 25</c:v>
-              </c:pt>
-              <c:pt idx="14">
-                <c:v>Dec 25</c:v>
-              </c:pt>
-              <c:pt idx="15">
-                <c:v>Jan 26</c:v>
-              </c:pt>
-              <c:pt idx="16">
-                <c:v>Feb 26</c:v>
-              </c:pt>
-              <c:pt idx="17">
-                <c:v>Mar 26</c:v>
-              </c:pt>
-              <c:pt idx="18">
-                <c:v>Apr 26</c:v>
-              </c:pt>
-            </c:strLit>
+            <c:numRef>
+              <c:f>Sheet1!$A$2:$A$20</c:f>
+              <c:numCache>
+                <c:formatCode>d\-mmm</c:formatCode>
+                <c:ptCount val="19"/>
+                <c:pt idx="0">
+                  <c:v>46319</c:v>
+                </c:pt>
+                <c:pt idx="1">
+                  <c:v>46350</c:v>
+                </c:pt>
+                <c:pt idx="2">
+                  <c:v>46380</c:v>
+                </c:pt>
+                <c:pt idx="3">
+                  <c:v>46047</c:v>
+                </c:pt>
+                <c:pt idx="4">
+                  <c:v>46078</c:v>
+                </c:pt>
+                <c:pt idx="5">
+                  <c:v>46106</c:v>
+                </c:pt>
+                <c:pt idx="6">
+                  <c:v>46137</c:v>
+                </c:pt>
+                <c:pt idx="7">
+                  <c:v>46167</c:v>
+                </c:pt>
+                <c:pt idx="8">
+                  <c:v>46198</c:v>
+                </c:pt>
+                <c:pt idx="9">
+                  <c:v>46228</c:v>
+                </c:pt>
+                <c:pt idx="10">
+                  <c:v>46259</c:v>
+                </c:pt>
+                <c:pt idx="11">
+                  <c:v>46290</c:v>
+                </c:pt>
+                <c:pt idx="12">
+                  <c:v>46320</c:v>
+                </c:pt>
+                <c:pt idx="13">
+                  <c:v>46351</c:v>
+                </c:pt>
+                <c:pt idx="14">
+                  <c:v>46381</c:v>
+                </c:pt>
+                <c:pt idx="15">
+                  <c:v>46048</c:v>
+                </c:pt>
+                <c:pt idx="16">
+                  <c:v>46079</c:v>
+                </c:pt>
+                <c:pt idx="17">
+                  <c:v>46107</c:v>
+                </c:pt>
+                <c:pt idx="18">
+                  <c:v>46138</c:v>
+                </c:pt>
+              </c:numCache>
+            </c:numRef>
           </c:cat>
           <c:val>
-            <c:numLit>
-              <c:formatCode>General</c:formatCode>
-              <c:ptCount val="19"/>
-              <c:pt idx="0">
-                <c:v>13.72</c:v>
-              </c:pt>
-              <c:pt idx="1">
-                <c:v>13.89</c:v>
-              </c:pt>
-              <c:pt idx="2">
-                <c:v>13.95</c:v>
-              </c:pt>
-              <c:pt idx="3">
-                <c:v>14.26</c:v>
-              </c:pt>
-              <c:pt idx="4">
-                <c:v>13.5</c:v>
-              </c:pt>
-              <c:pt idx="5">
-                <c:v>14.68</c:v>
-              </c:pt>
-              <c:pt idx="6">
-                <c:v>14.4</c:v>
-              </c:pt>
-              <c:pt idx="7">
-                <c:v>14.21</c:v>
-              </c:pt>
-              <c:pt idx="8">
-                <c:v>13.68</c:v>
-              </c:pt>
-              <c:pt idx="9">
-                <c:v>14.16</c:v>
-              </c:pt>
-              <c:pt idx="10">
-                <c:v>13.82</c:v>
-              </c:pt>
-              <c:pt idx="11">
-                <c:v>14.16</c:v>
-              </c:pt>
-              <c:pt idx="12">
-                <c:v>14.16</c:v>
-              </c:pt>
-              <c:pt idx="13">
-                <c:v>14</c:v>
-              </c:pt>
-              <c:pt idx="14">
-                <c:v>14.48</c:v>
-              </c:pt>
-              <c:pt idx="15">
-                <c:v>14.19</c:v>
-              </c:pt>
-              <c:pt idx="16">
-                <c:v>14.25</c:v>
-              </c:pt>
-              <c:pt idx="17">
-                <c:v>13.34</c:v>
-              </c:pt>
-              <c:pt idx="18">
-                <c:v>14.79</c:v>
-              </c:pt>
-            </c:numLit>
+            <c:numRef>
+              <c:f>Sheet1!$B$2:$B$20</c:f>
+              <c:numCache>
+                <c:formatCode>General</c:formatCode>
+                <c:ptCount val="19"/>
+                <c:pt idx="0">
+                  <c:v>13.72</c:v>
+                </c:pt>
+                <c:pt idx="1">
+                  <c:v>13.89</c:v>
+                </c:pt>
+                <c:pt idx="2">
+                  <c:v>13.95</c:v>
+                </c:pt>
+                <c:pt idx="3">
+                  <c:v>14.26</c:v>
+                </c:pt>
+                <c:pt idx="4">
+                  <c:v>13.5</c:v>
+                </c:pt>
+                <c:pt idx="5">
+                  <c:v>14.68</c:v>
+                </c:pt>
+                <c:pt idx="6">
+                  <c:v>14.4</c:v>
+                </c:pt>
+                <c:pt idx="7">
+                  <c:v>14.21</c:v>
+                </c:pt>
+                <c:pt idx="8">
+                  <c:v>13.68</c:v>
+                </c:pt>
+                <c:pt idx="9">
+                  <c:v>14.16</c:v>
+                </c:pt>
+                <c:pt idx="10">
+                  <c:v>13.82</c:v>
+                </c:pt>
+                <c:pt idx="11">
+                  <c:v>14.16</c:v>
+                </c:pt>
+                <c:pt idx="12">
+                  <c:v>14.16</c:v>
+                </c:pt>
+                <c:pt idx="13">
+                  <c:v>14</c:v>
+                </c:pt>
+                <c:pt idx="14">
+                  <c:v>14.48</c:v>
+                </c:pt>
+                <c:pt idx="15">
+                  <c:v>14.19</c:v>
+                </c:pt>
+                <c:pt idx="16">
+                  <c:v>14.25</c:v>
+                </c:pt>
+                <c:pt idx="17">
+                  <c:v>13.34</c:v>
+                </c:pt>
+                <c:pt idx="18">
+                  <c:v>14.79</c:v>
+                </c:pt>
+              </c:numCache>
+            </c:numRef>
           </c:val>
           <c:extLst>
             <c:ext xmlns:c16="http://schemas.microsoft.com/office/drawing/2014/chart" uri="{C3380CC4-5D6E-409C-BE32-E72D297353CC}">
@@ -3776,7 +3793,15 @@
           <c:idx val="1"/>
           <c:order val="1"/>
           <c:tx>
-            <c:v>_gap</c:v>
+            <c:strRef>
+              <c:f>Sheet1!$C$1</c:f>
+              <c:strCache>
+                <c:ptCount val="1"/>
+                <c:pt idx="0">
+                  <c:v>_gap</c:v>
+                </c:pt>
+              </c:strCache>
+            </c:strRef>
           </c:tx>
           <c:spPr>
             <a:solidFill>
@@ -3789,129 +3814,136 @@
             </a:ln>
           </c:spPr>
           <c:cat>
-            <c:strLit>
-              <c:ptCount val="19"/>
-              <c:pt idx="0">
-                <c:v>Oct 24</c:v>
-              </c:pt>
-              <c:pt idx="1">
-                <c:v>Nov 24</c:v>
-              </c:pt>
-              <c:pt idx="2">
-                <c:v>Dec 24</c:v>
-              </c:pt>
-              <c:pt idx="3">
-                <c:v>Jan 25</c:v>
-              </c:pt>
-              <c:pt idx="4">
-                <c:v>Feb 25</c:v>
-              </c:pt>
-              <c:pt idx="5">
-                <c:v>Mar 25</c:v>
-              </c:pt>
-              <c:pt idx="6">
-                <c:v>Apr 25</c:v>
-              </c:pt>
-              <c:pt idx="7">
-                <c:v>May 25</c:v>
-              </c:pt>
-              <c:pt idx="8">
-                <c:v>Jun 25</c:v>
-              </c:pt>
-              <c:pt idx="9">
-                <c:v>Jul 25</c:v>
-              </c:pt>
-              <c:pt idx="10">
-                <c:v>Aug 25</c:v>
-              </c:pt>
-              <c:pt idx="11">
-                <c:v>Sep 25</c:v>
-              </c:pt>
-              <c:pt idx="12">
-                <c:v>Oct 25</c:v>
-              </c:pt>
-              <c:pt idx="13">
-                <c:v>Nov 25</c:v>
-              </c:pt>
-              <c:pt idx="14">
-                <c:v>Dec 25</c:v>
-              </c:pt>
-              <c:pt idx="15">
-                <c:v>Jan 26</c:v>
-              </c:pt>
-              <c:pt idx="16">
-                <c:v>Feb 26</c:v>
-              </c:pt>
-              <c:pt idx="17">
-                <c:v>Mar 26</c:v>
-              </c:pt>
-              <c:pt idx="18">
-                <c:v>Apr 26</c:v>
-              </c:pt>
-            </c:strLit>
+            <c:numRef>
+              <c:f>Sheet1!$A$2:$A$20</c:f>
+              <c:numCache>
+                <c:formatCode>d\-mmm</c:formatCode>
+                <c:ptCount val="19"/>
+                <c:pt idx="0">
+                  <c:v>46319</c:v>
+                </c:pt>
+                <c:pt idx="1">
+                  <c:v>46350</c:v>
+                </c:pt>
+                <c:pt idx="2">
+                  <c:v>46380</c:v>
+                </c:pt>
+                <c:pt idx="3">
+                  <c:v>46047</c:v>
+                </c:pt>
+                <c:pt idx="4">
+                  <c:v>46078</c:v>
+                </c:pt>
+                <c:pt idx="5">
+                  <c:v>46106</c:v>
+                </c:pt>
+                <c:pt idx="6">
+                  <c:v>46137</c:v>
+                </c:pt>
+                <c:pt idx="7">
+                  <c:v>46167</c:v>
+                </c:pt>
+                <c:pt idx="8">
+                  <c:v>46198</c:v>
+                </c:pt>
+                <c:pt idx="9">
+                  <c:v>46228</c:v>
+                </c:pt>
+                <c:pt idx="10">
+                  <c:v>46259</c:v>
+                </c:pt>
+                <c:pt idx="11">
+                  <c:v>46290</c:v>
+                </c:pt>
+                <c:pt idx="12">
+                  <c:v>46320</c:v>
+                </c:pt>
+                <c:pt idx="13">
+                  <c:v>46351</c:v>
+                </c:pt>
+                <c:pt idx="14">
+                  <c:v>46381</c:v>
+                </c:pt>
+                <c:pt idx="15">
+                  <c:v>46048</c:v>
+                </c:pt>
+                <c:pt idx="16">
+                  <c:v>46079</c:v>
+                </c:pt>
+                <c:pt idx="17">
+                  <c:v>46107</c:v>
+                </c:pt>
+                <c:pt idx="18">
+                  <c:v>46138</c:v>
+                </c:pt>
+              </c:numCache>
+            </c:numRef>
           </c:cat>
           <c:val>
-            <c:numLit>
-              <c:formatCode>General</c:formatCode>
-              <c:ptCount val="19"/>
-              <c:pt idx="0">
-                <c:v>1.05</c:v>
-              </c:pt>
-              <c:pt idx="1">
-                <c:v>1.38</c:v>
-              </c:pt>
-              <c:pt idx="2">
-                <c:v>1.49</c:v>
-              </c:pt>
-              <c:pt idx="3">
-                <c:v>0.89</c:v>
-              </c:pt>
-              <c:pt idx="4">
-                <c:v>0.89</c:v>
-              </c:pt>
-              <c:pt idx="5">
-                <c:v>0.7</c:v>
-              </c:pt>
-              <c:pt idx="6">
-                <c:v>1.24</c:v>
-              </c:pt>
-              <c:pt idx="7">
-                <c:v>0.92</c:v>
-              </c:pt>
-              <c:pt idx="8">
-                <c:v>1.72</c:v>
-              </c:pt>
-              <c:pt idx="9">
-                <c:v>0.76</c:v>
-              </c:pt>
-              <c:pt idx="10">
-                <c:v>0.59</c:v>
-              </c:pt>
-              <c:pt idx="11">
-                <c:v>0.55000000000000004</c:v>
-              </c:pt>
-              <c:pt idx="12">
-                <c:v>0.56000000000000005</c:v>
-              </c:pt>
-              <c:pt idx="13">
-                <c:v>0.67</c:v>
-              </c:pt>
-              <c:pt idx="14">
-                <c:v>0.94</c:v>
-              </c:pt>
-              <c:pt idx="15">
-                <c:v>0.67</c:v>
-              </c:pt>
-              <c:pt idx="16">
-                <c:v>0.59</c:v>
-              </c:pt>
-              <c:pt idx="17">
-                <c:v>1.29</c:v>
-              </c:pt>
-              <c:pt idx="18">
-                <c:v>1.1399999999999999</c:v>
-              </c:pt>
-            </c:numLit>
+            <c:numRef>
+              <c:f>Sheet1!$C$2:$C$20</c:f>
+              <c:numCache>
+                <c:formatCode>General</c:formatCode>
+                <c:ptCount val="19"/>
+                <c:pt idx="0">
+                  <c:v>1.05</c:v>
+                </c:pt>
+                <c:pt idx="1">
+                  <c:v>1.38</c:v>
+                </c:pt>
+                <c:pt idx="2">
+                  <c:v>1.49</c:v>
+                </c:pt>
+                <c:pt idx="3">
+                  <c:v>0.89</c:v>
+                </c:pt>
+                <c:pt idx="4">
+                  <c:v>0.89</c:v>
+                </c:pt>
+                <c:pt idx="5">
+                  <c:v>0.7</c:v>
+                </c:pt>
+                <c:pt idx="6">
+                  <c:v>1.24</c:v>
+                </c:pt>
+                <c:pt idx="7">
+                  <c:v>0.92</c:v>
+                </c:pt>
+                <c:pt idx="8">
+                  <c:v>1.72</c:v>
+                </c:pt>
+                <c:pt idx="9">
+                  <c:v>0.76</c:v>
+                </c:pt>
+                <c:pt idx="10">
+                  <c:v>0.59</c:v>
+                </c:pt>
+                <c:pt idx="11">
+                  <c:v>0.55000000000000004</c:v>
+                </c:pt>
+                <c:pt idx="12">
+                  <c:v>0.56000000000000005</c:v>
+                </c:pt>
+                <c:pt idx="13">
+                  <c:v>0.67</c:v>
+                </c:pt>
+                <c:pt idx="14">
+                  <c:v>0.94</c:v>
+                </c:pt>
+                <c:pt idx="15">
+                  <c:v>0.67</c:v>
+                </c:pt>
+                <c:pt idx="16">
+                  <c:v>0.59</c:v>
+                </c:pt>
+                <c:pt idx="17">
+                  <c:v>1.29</c:v>
+                </c:pt>
+                <c:pt idx="18">
+                  <c:v>1.1399999999999999</c:v>
+                </c:pt>
+              </c:numCache>
+            </c:numRef>
           </c:val>
           <c:extLst>
             <c:ext xmlns:c16="http://schemas.microsoft.com/office/drawing/2014/chart" uri="{C3380CC4-5D6E-409C-BE32-E72D297353CC}">
@@ -3937,6 +3969,515 @@
           <c:idx val="2"/>
           <c:order val="2"/>
           <c:tx>
+            <c:strRef>
+              <c:f>Sheet1!$E$1</c:f>
+              <c:strCache>
+                <c:ptCount val="1"/>
+                <c:pt idx="0">
+                  <c:v>CRV-exposed PCL clients</c:v>
+                </c:pt>
+              </c:strCache>
+            </c:strRef>
+          </c:tx>
+          <c:spPr>
+            <a:ln w="28575">
+              <a:solidFill>
+                <a:srgbClr val="C2410C"/>
+              </a:solidFill>
+            </a:ln>
+          </c:spPr>
+          <c:marker>
+            <c:symbol val="circle"/>
+            <c:size val="5"/>
+            <c:spPr>
+              <a:solidFill>
+                <a:srgbClr val="C2410C"/>
+              </a:solidFill>
+              <a:ln>
+                <a:solidFill>
+                  <a:srgbClr val="C2410C"/>
+                </a:solidFill>
+              </a:ln>
+            </c:spPr>
+          </c:marker>
+          <c:cat>
+            <c:numRef>
+              <c:f>Sheet1!$D$2:$D$20</c:f>
+              <c:numCache>
+                <c:formatCode>d\-mmm</c:formatCode>
+                <c:ptCount val="19"/>
+                <c:pt idx="0">
+                  <c:v>46319</c:v>
+                </c:pt>
+                <c:pt idx="1">
+                  <c:v>46350</c:v>
+                </c:pt>
+                <c:pt idx="2">
+                  <c:v>46380</c:v>
+                </c:pt>
+                <c:pt idx="3">
+                  <c:v>46047</c:v>
+                </c:pt>
+                <c:pt idx="4">
+                  <c:v>46078</c:v>
+                </c:pt>
+                <c:pt idx="5">
+                  <c:v>46106</c:v>
+                </c:pt>
+                <c:pt idx="6">
+                  <c:v>46137</c:v>
+                </c:pt>
+                <c:pt idx="7">
+                  <c:v>46167</c:v>
+                </c:pt>
+                <c:pt idx="8">
+                  <c:v>46198</c:v>
+                </c:pt>
+                <c:pt idx="9">
+                  <c:v>46228</c:v>
+                </c:pt>
+                <c:pt idx="10">
+                  <c:v>46259</c:v>
+                </c:pt>
+                <c:pt idx="11">
+                  <c:v>46290</c:v>
+                </c:pt>
+                <c:pt idx="12">
+                  <c:v>46320</c:v>
+                </c:pt>
+                <c:pt idx="13">
+                  <c:v>46351</c:v>
+                </c:pt>
+                <c:pt idx="14">
+                  <c:v>46381</c:v>
+                </c:pt>
+                <c:pt idx="15">
+                  <c:v>46048</c:v>
+                </c:pt>
+                <c:pt idx="16">
+                  <c:v>46079</c:v>
+                </c:pt>
+                <c:pt idx="17">
+                  <c:v>46107</c:v>
+                </c:pt>
+                <c:pt idx="18">
+                  <c:v>46138</c:v>
+                </c:pt>
+              </c:numCache>
+            </c:numRef>
+          </c:cat>
+          <c:val>
+            <c:numRef>
+              <c:f>Sheet1!$E$2:$E$20</c:f>
+              <c:numCache>
+                <c:formatCode>General</c:formatCode>
+                <c:ptCount val="19"/>
+                <c:pt idx="0">
+                  <c:v>13.72</c:v>
+                </c:pt>
+                <c:pt idx="1">
+                  <c:v>13.89</c:v>
+                </c:pt>
+                <c:pt idx="2">
+                  <c:v>13.95</c:v>
+                </c:pt>
+                <c:pt idx="3">
+                  <c:v>14.26</c:v>
+                </c:pt>
+                <c:pt idx="4">
+                  <c:v>13.5</c:v>
+                </c:pt>
+                <c:pt idx="5">
+                  <c:v>14.68</c:v>
+                </c:pt>
+                <c:pt idx="6">
+                  <c:v>14.4</c:v>
+                </c:pt>
+                <c:pt idx="7">
+                  <c:v>14.21</c:v>
+                </c:pt>
+                <c:pt idx="8">
+                  <c:v>13.68</c:v>
+                </c:pt>
+                <c:pt idx="9">
+                  <c:v>14.16</c:v>
+                </c:pt>
+                <c:pt idx="10">
+                  <c:v>13.82</c:v>
+                </c:pt>
+                <c:pt idx="11">
+                  <c:v>14.16</c:v>
+                </c:pt>
+                <c:pt idx="12">
+                  <c:v>14.16</c:v>
+                </c:pt>
+                <c:pt idx="13">
+                  <c:v>14</c:v>
+                </c:pt>
+                <c:pt idx="14">
+                  <c:v>14.48</c:v>
+                </c:pt>
+                <c:pt idx="15">
+                  <c:v>14.19</c:v>
+                </c:pt>
+                <c:pt idx="16">
+                  <c:v>14.25</c:v>
+                </c:pt>
+                <c:pt idx="17">
+                  <c:v>13.34</c:v>
+                </c:pt>
+                <c:pt idx="18">
+                  <c:v>14.79</c:v>
+                </c:pt>
+              </c:numCache>
+            </c:numRef>
+          </c:val>
+          <c:smooth val="0"/>
+          <c:extLst>
+            <c:ext xmlns:c16="http://schemas.microsoft.com/office/drawing/2014/chart" uri="{C3380CC4-5D6E-409C-BE32-E72D297353CC}">
+              <c16:uniqueId val="{00000002-E475-4793-8B83-231A20EA95D5}"/>
+            </c:ext>
+          </c:extLst>
+        </c:ser>
+        <c:ser>
+          <c:idx val="3"/>
+          <c:order val="3"/>
+          <c:tx>
+            <c:strRef>
+              <c:f>Sheet1!$F$1</c:f>
+              <c:strCache>
+                <c:ptCount val="1"/>
+                <c:pt idx="0">
+                  <c:v>Comparable PCL clients (no CRV)</c:v>
+                </c:pt>
+              </c:strCache>
+            </c:strRef>
+          </c:tx>
+          <c:spPr>
+            <a:ln w="28575">
+              <a:solidFill>
+                <a:srgbClr val="1F4E79"/>
+              </a:solidFill>
+            </a:ln>
+          </c:spPr>
+          <c:marker>
+            <c:symbol val="circle"/>
+            <c:size val="5"/>
+            <c:spPr>
+              <a:solidFill>
+                <a:srgbClr val="1F4E79"/>
+              </a:solidFill>
+              <a:ln>
+                <a:solidFill>
+                  <a:srgbClr val="1F4E79"/>
+                </a:solidFill>
+              </a:ln>
+            </c:spPr>
+          </c:marker>
+          <c:cat>
+            <c:numRef>
+              <c:f>Sheet1!$D$2:$D$20</c:f>
+              <c:numCache>
+                <c:formatCode>d\-mmm</c:formatCode>
+                <c:ptCount val="19"/>
+                <c:pt idx="0">
+                  <c:v>46319</c:v>
+                </c:pt>
+                <c:pt idx="1">
+                  <c:v>46350</c:v>
+                </c:pt>
+                <c:pt idx="2">
+                  <c:v>46380</c:v>
+                </c:pt>
+                <c:pt idx="3">
+                  <c:v>46047</c:v>
+                </c:pt>
+                <c:pt idx="4">
+                  <c:v>46078</c:v>
+                </c:pt>
+                <c:pt idx="5">
+                  <c:v>46106</c:v>
+                </c:pt>
+                <c:pt idx="6">
+                  <c:v>46137</c:v>
+                </c:pt>
+                <c:pt idx="7">
+                  <c:v>46167</c:v>
+                </c:pt>
+                <c:pt idx="8">
+                  <c:v>46198</c:v>
+                </c:pt>
+                <c:pt idx="9">
+                  <c:v>46228</c:v>
+                </c:pt>
+                <c:pt idx="10">
+                  <c:v>46259</c:v>
+                </c:pt>
+                <c:pt idx="11">
+                  <c:v>46290</c:v>
+                </c:pt>
+                <c:pt idx="12">
+                  <c:v>46320</c:v>
+                </c:pt>
+                <c:pt idx="13">
+                  <c:v>46351</c:v>
+                </c:pt>
+                <c:pt idx="14">
+                  <c:v>46381</c:v>
+                </c:pt>
+                <c:pt idx="15">
+                  <c:v>46048</c:v>
+                </c:pt>
+                <c:pt idx="16">
+                  <c:v>46079</c:v>
+                </c:pt>
+                <c:pt idx="17">
+                  <c:v>46107</c:v>
+                </c:pt>
+                <c:pt idx="18">
+                  <c:v>46138</c:v>
+                </c:pt>
+              </c:numCache>
+            </c:numRef>
+          </c:cat>
+          <c:val>
+            <c:numRef>
+              <c:f>Sheet1!$F$2:$F$20</c:f>
+              <c:numCache>
+                <c:formatCode>General</c:formatCode>
+                <c:ptCount val="19"/>
+                <c:pt idx="0">
+                  <c:v>14.77</c:v>
+                </c:pt>
+                <c:pt idx="1">
+                  <c:v>15.27</c:v>
+                </c:pt>
+                <c:pt idx="2">
+                  <c:v>15.44</c:v>
+                </c:pt>
+                <c:pt idx="3">
+                  <c:v>15.15</c:v>
+                </c:pt>
+                <c:pt idx="4">
+                  <c:v>14.39</c:v>
+                </c:pt>
+                <c:pt idx="5">
+                  <c:v>15.38</c:v>
+                </c:pt>
+                <c:pt idx="6">
+                  <c:v>15.64</c:v>
+                </c:pt>
+                <c:pt idx="7">
+                  <c:v>15.13</c:v>
+                </c:pt>
+                <c:pt idx="8">
+                  <c:v>15.4</c:v>
+                </c:pt>
+                <c:pt idx="9">
+                  <c:v>14.92</c:v>
+                </c:pt>
+                <c:pt idx="10">
+                  <c:v>14.41</c:v>
+                </c:pt>
+                <c:pt idx="11">
+                  <c:v>14.71</c:v>
+                </c:pt>
+                <c:pt idx="12">
+                  <c:v>14.72</c:v>
+                </c:pt>
+                <c:pt idx="13">
+                  <c:v>14.67</c:v>
+                </c:pt>
+                <c:pt idx="14">
+                  <c:v>15.42</c:v>
+                </c:pt>
+                <c:pt idx="15">
+                  <c:v>14.86</c:v>
+                </c:pt>
+                <c:pt idx="16">
+                  <c:v>14.84</c:v>
+                </c:pt>
+                <c:pt idx="17">
+                  <c:v>14.63</c:v>
+                </c:pt>
+                <c:pt idx="18">
+                  <c:v>15.93</c:v>
+                </c:pt>
+              </c:numCache>
+            </c:numRef>
+          </c:val>
+          <c:smooth val="0"/>
+          <c:extLst>
+            <c:ext xmlns:c16="http://schemas.microsoft.com/office/drawing/2014/chart" uri="{C3380CC4-5D6E-409C-BE32-E72D297353CC}">
+              <c16:uniqueId val="{00000003-E475-4793-8B83-231A20EA95D5}"/>
+            </c:ext>
+          </c:extLst>
+        </c:ser>
+        <c:dLbls>
+          <c:showLegendKey val="0"/>
+          <c:showVal val="0"/>
+          <c:showCatName val="0"/>
+          <c:showSerName val="0"/>
+          <c:showPercent val="0"/>
+          <c:showBubbleSize val="0"/>
+        </c:dLbls>
+        <c:marker val="1"/>
+        <c:smooth val="0"/>
+        <c:axId val="1"/>
+        <c:axId val="2"/>
+      </c:lineChart>
+      <c:dateAx>
+        <c:axId val="1"/>
+        <c:scaling>
+          <c:orientation val="minMax"/>
+        </c:scaling>
+        <c:delete val="0"/>
+        <c:axPos val="b"/>
+        <c:numFmt formatCode="General" sourceLinked="0"/>
+        <c:majorTickMark val="none"/>
+        <c:minorTickMark val="none"/>
+        <c:tickLblPos val="nextTo"/>
+        <c:txPr>
+          <a:bodyPr rot="-1800000"/>
+          <a:lstStyle/>
+          <a:p>
+            <a:pPr>
+              <a:defRPr sz="900">
+                <a:solidFill>
+                  <a:srgbClr val="374151"/>
+                </a:solidFill>
+              </a:defRPr>
+            </a:pPr>
+            <a:endParaRPr lang="en-US"/>
+          </a:p>
+        </c:txPr>
+        <c:crossAx val="2"/>
+        <c:crosses val="autoZero"/>
+        <c:auto val="1"/>
+        <c:lblOffset val="100"/>
+        <c:baseTimeUnit val="days"/>
+      </c:dateAx>
+      <c:valAx>
+        <c:axId val="2"/>
+        <c:scaling>
+          <c:orientation val="minMax"/>
+          <c:max val="18"/>
+          <c:min val="11"/>
+        </c:scaling>
+        <c:delete val="0"/>
+        <c:axPos val="l"/>
+        <c:majorGridlines>
+          <c:spPr>
+            <a:ln w="6350">
+              <a:solidFill>
+                <a:srgbClr val="E5E7EB"/>
+              </a:solidFill>
+            </a:ln>
+          </c:spPr>
+        </c:majorGridlines>
+        <c:numFmt formatCode="0&quot;%&quot;" sourceLinked="0"/>
+        <c:majorTickMark val="out"/>
+        <c:minorTickMark val="none"/>
+        <c:tickLblPos val="nextTo"/>
+        <c:txPr>
+          <a:bodyPr/>
+          <a:lstStyle/>
+          <a:p>
+            <a:pPr>
+              <a:defRPr sz="1000">
+                <a:solidFill>
+                  <a:srgbClr val="374151"/>
+                </a:solidFill>
+              </a:defRPr>
+            </a:pPr>
+            <a:endParaRPr lang="en-US"/>
+          </a:p>
+        </c:txPr>
+        <c:crossAx val="1"/>
+        <c:crosses val="autoZero"/>
+        <c:crossBetween val="between"/>
+      </c:valAx>
+    </c:plotArea>
+    <c:plotVisOnly val="1"/>
+    <c:dispBlanksAs val="zero"/>
+    <c:showDLblsOverMax val="1"/>
+  </c:chart>
+  <c:externalData r:id="rId1">
+    <c:autoUpdate val="0"/>
+  </c:externalData>
+</c:chartSpace>
+</file>
+
+<file path=ppt/charts/chart8.xml><?xml version="1.0" encoding="utf-8"?>
+<c:chartSpace xmlns:c="http://schemas.openxmlformats.org/drawingml/2006/chart" xmlns:a="http://schemas.openxmlformats.org/drawingml/2006/main" xmlns:r="http://schemas.openxmlformats.org/officeDocument/2006/relationships" xmlns:c16r2="http://schemas.microsoft.com/office/drawing/2015/06/chart">
+  <c:date1904 val="1"/>
+  <c:lang val="en-US"/>
+  <c:roundedCorners val="1"/>
+  <c:style val="2"/>
+  <c:chart>
+    <c:title>
+      <c:tx>
+        <c:rich>
+          <a:bodyPr wrap="square" anchor="t"/>
+          <a:lstStyle/>
+          <a:p>
+            <a:pPr algn="l">
+              <a:defRPr sz="1200" b="1">
+                <a:solidFill>
+                  <a:srgbClr val="1F2937"/>
+                </a:solidFill>
+              </a:defRPr>
+            </a:pPr>
+            <a:r>
+              <a:rPr lang="en-US" sz="1200" b="1">
+                <a:solidFill>
+                  <a:srgbClr val="1F2937"/>
+                </a:solidFill>
+              </a:rPr>
+              <a:t>PCL conversion is lower when clients are also exposed to CRV —</a:t>
+            </a:r>
+          </a:p>
+          <a:p>
+            <a:pPr algn="l">
+              <a:defRPr sz="1200" b="1">
+                <a:solidFill>
+                  <a:srgbClr val="1F2937"/>
+                </a:solidFill>
+              </a:defRPr>
+            </a:pPr>
+            <a:r>
+              <a:rPr lang="en-US" sz="1200" b="1">
+                <a:solidFill>
+                  <a:srgbClr val="1F2937"/>
+                </a:solidFill>
+              </a:rPr>
+              <a:t>~65K conversions recoverable by discontinuing CRV</a:t>
+            </a:r>
+          </a:p>
+        </c:rich>
+      </c:tx>
+      <c:overlay val="0"/>
+    </c:title>
+    <c:autoTitleDeleted val="0"/>
+    <c:plotArea>
+      <c:layout>
+        <c:manualLayout>
+          <c:layoutTarget val="inner"/>
+          <c:xMode val="edge"/>
+          <c:yMode val="edge"/>
+          <c:x val="0.1"/>
+          <c:y val="0.22"/>
+          <c:w val="0.74"/>
+          <c:h val="0.62"/>
+        </c:manualLayout>
+      </c:layout>
+      <c:lineChart>
+        <c:grouping val="standard"/>
+        <c:varyColors val="0"/>
+        <c:ser>
+          <c:idx val="0"/>
+          <c:order val="0"/>
+          <c:tx>
             <c:v>CRV-exposed PCL clients</c:v>
           </c:tx>
           <c:spPr>
@@ -4088,13 +4629,13 @@
           <c:smooth val="0"/>
           <c:extLst>
             <c:ext xmlns:c16="http://schemas.microsoft.com/office/drawing/2014/chart" uri="{C3380CC4-5D6E-409C-BE32-E72D297353CC}">
-              <c16:uniqueId val="{00000002-E475-4793-8B83-231A20EA95D5}"/>
+              <c16:uniqueId val="{00000000-3734-4493-9CE6-3E23C250A3C3}"/>
             </c:ext>
           </c:extLst>
         </c:ser>
         <c:ser>
-          <c:idx val="3"/>
-          <c:order val="3"/>
+          <c:idx val="1"/>
+          <c:order val="1"/>
           <c:tx>
             <c:v>Comparable PCL clients (no CRV)</c:v>
           </c:tx>
@@ -4247,7 +4788,484 @@
           <c:smooth val="0"/>
           <c:extLst>
             <c:ext xmlns:c16="http://schemas.microsoft.com/office/drawing/2014/chart" uri="{C3380CC4-5D6E-409C-BE32-E72D297353CC}">
-              <c16:uniqueId val="{00000003-E475-4793-8B83-231A20EA95D5}"/>
+              <c16:uniqueId val="{00000001-3734-4493-9CE6-3E23C250A3C3}"/>
+            </c:ext>
+          </c:extLst>
+        </c:ser>
+        <c:dLbls>
+          <c:showLegendKey val="0"/>
+          <c:showVal val="0"/>
+          <c:showCatName val="0"/>
+          <c:showSerName val="0"/>
+          <c:showPercent val="0"/>
+          <c:showBubbleSize val="0"/>
+        </c:dLbls>
+        <c:marker val="1"/>
+        <c:smooth val="0"/>
+        <c:axId val="1"/>
+        <c:axId val="2"/>
+      </c:lineChart>
+      <c:catAx>
+        <c:axId val="1"/>
+        <c:scaling>
+          <c:orientation val="minMax"/>
+        </c:scaling>
+        <c:delete val="0"/>
+        <c:axPos val="b"/>
+        <c:numFmt formatCode="General" sourceLinked="0"/>
+        <c:majorTickMark val="none"/>
+        <c:minorTickMark val="none"/>
+        <c:tickLblPos val="nextTo"/>
+        <c:txPr>
+          <a:bodyPr rot="-1800000"/>
+          <a:lstStyle/>
+          <a:p>
+            <a:pPr>
+              <a:defRPr sz="900">
+                <a:solidFill>
+                  <a:srgbClr val="374151"/>
+                </a:solidFill>
+              </a:defRPr>
+            </a:pPr>
+            <a:endParaRPr lang="en-US"/>
+          </a:p>
+        </c:txPr>
+        <c:crossAx val="2"/>
+        <c:crosses val="autoZero"/>
+        <c:auto val="1"/>
+        <c:lblAlgn val="ctr"/>
+        <c:lblOffset val="100"/>
+        <c:noMultiLvlLbl val="1"/>
+      </c:catAx>
+      <c:valAx>
+        <c:axId val="2"/>
+        <c:scaling>
+          <c:orientation val="minMax"/>
+          <c:max val="18"/>
+          <c:min val="11"/>
+        </c:scaling>
+        <c:delete val="0"/>
+        <c:axPos val="l"/>
+        <c:majorGridlines>
+          <c:spPr>
+            <a:ln w="6350">
+              <a:solidFill>
+                <a:srgbClr val="E5E7EB"/>
+              </a:solidFill>
+            </a:ln>
+          </c:spPr>
+        </c:majorGridlines>
+        <c:numFmt formatCode="0&quot;%&quot;" sourceLinked="0"/>
+        <c:majorTickMark val="out"/>
+        <c:minorTickMark val="none"/>
+        <c:tickLblPos val="nextTo"/>
+        <c:txPr>
+          <a:bodyPr/>
+          <a:lstStyle/>
+          <a:p>
+            <a:pPr>
+              <a:defRPr sz="1000">
+                <a:solidFill>
+                  <a:srgbClr val="374151"/>
+                </a:solidFill>
+              </a:defRPr>
+            </a:pPr>
+            <a:endParaRPr lang="en-US"/>
+          </a:p>
+        </c:txPr>
+        <c:crossAx val="1"/>
+        <c:crosses val="autoZero"/>
+        <c:crossBetween val="between"/>
+      </c:valAx>
+    </c:plotArea>
+    <c:plotVisOnly val="1"/>
+    <c:dispBlanksAs val="zero"/>
+    <c:showDLblsOverMax val="1"/>
+  </c:chart>
+</c:chartSpace>
+</file>
+
+<file path=ppt/charts/chart9.xml><?xml version="1.0" encoding="utf-8"?>
+<c:chartSpace xmlns:c="http://schemas.openxmlformats.org/drawingml/2006/chart" xmlns:a="http://schemas.openxmlformats.org/drawingml/2006/main" xmlns:r="http://schemas.openxmlformats.org/officeDocument/2006/relationships" xmlns:c16r2="http://schemas.microsoft.com/office/drawing/2015/06/chart">
+  <c:date1904 val="1"/>
+  <c:lang val="en-US"/>
+  <c:roundedCorners val="1"/>
+  <c:style val="2"/>
+  <c:chart>
+    <c:title>
+      <c:tx>
+        <c:rich>
+          <a:bodyPr wrap="square" anchor="t"/>
+          <a:lstStyle/>
+          <a:p>
+            <a:pPr algn="l">
+              <a:defRPr sz="1200" b="1">
+                <a:solidFill>
+                  <a:srgbClr val="1F2937"/>
+                </a:solidFill>
+              </a:defRPr>
+            </a:pPr>
+            <a:r>
+              <a:rPr lang="en-US" sz="1200" b="1">
+                <a:solidFill>
+                  <a:srgbClr val="1F2937"/>
+                </a:solidFill>
+              </a:rPr>
+              <a:t>PCL conversion is lower when clients are also exposed to CRV —</a:t>
+            </a:r>
+          </a:p>
+          <a:p>
+            <a:pPr algn="l">
+              <a:defRPr sz="1200" b="1">
+                <a:solidFill>
+                  <a:srgbClr val="1F2937"/>
+                </a:solidFill>
+              </a:defRPr>
+            </a:pPr>
+            <a:r>
+              <a:rPr lang="en-US" sz="1200" b="1">
+                <a:solidFill>
+                  <a:srgbClr val="1F2937"/>
+                </a:solidFill>
+              </a:rPr>
+              <a:t>~65K conversions recoverable by discontinuing CRV</a:t>
+            </a:r>
+          </a:p>
+        </c:rich>
+      </c:tx>
+      <c:overlay val="0"/>
+    </c:title>
+    <c:autoTitleDeleted val="0"/>
+    <c:plotArea>
+      <c:layout>
+        <c:manualLayout>
+          <c:layoutTarget val="inner"/>
+          <c:xMode val="edge"/>
+          <c:yMode val="edge"/>
+          <c:x val="0.1"/>
+          <c:y val="0.22"/>
+          <c:w val="0.74"/>
+          <c:h val="0.62"/>
+        </c:manualLayout>
+      </c:layout>
+      <c:lineChart>
+        <c:grouping val="standard"/>
+        <c:varyColors val="0"/>
+        <c:ser>
+          <c:idx val="0"/>
+          <c:order val="0"/>
+          <c:tx>
+            <c:v>CRV-exposed PCL clients</c:v>
+          </c:tx>
+          <c:spPr>
+            <a:ln w="28575">
+              <a:solidFill>
+                <a:srgbClr val="C2410C"/>
+              </a:solidFill>
+            </a:ln>
+          </c:spPr>
+          <c:marker>
+            <c:symbol val="circle"/>
+            <c:size val="5"/>
+            <c:spPr>
+              <a:solidFill>
+                <a:srgbClr val="C2410C"/>
+              </a:solidFill>
+              <a:ln>
+                <a:solidFill>
+                  <a:srgbClr val="C2410C"/>
+                </a:solidFill>
+              </a:ln>
+            </c:spPr>
+          </c:marker>
+          <c:cat>
+            <c:strLit>
+              <c:ptCount val="19"/>
+              <c:pt idx="0">
+                <c:v>Oct 24</c:v>
+              </c:pt>
+              <c:pt idx="1">
+                <c:v>Nov 24</c:v>
+              </c:pt>
+              <c:pt idx="2">
+                <c:v>Dec 24</c:v>
+              </c:pt>
+              <c:pt idx="3">
+                <c:v>Jan 25</c:v>
+              </c:pt>
+              <c:pt idx="4">
+                <c:v>Feb 25</c:v>
+              </c:pt>
+              <c:pt idx="5">
+                <c:v>Mar 25</c:v>
+              </c:pt>
+              <c:pt idx="6">
+                <c:v>Apr 25</c:v>
+              </c:pt>
+              <c:pt idx="7">
+                <c:v>May 25</c:v>
+              </c:pt>
+              <c:pt idx="8">
+                <c:v>Jun 25</c:v>
+              </c:pt>
+              <c:pt idx="9">
+                <c:v>Jul 25</c:v>
+              </c:pt>
+              <c:pt idx="10">
+                <c:v>Aug 25</c:v>
+              </c:pt>
+              <c:pt idx="11">
+                <c:v>Sep 25</c:v>
+              </c:pt>
+              <c:pt idx="12">
+                <c:v>Oct 25</c:v>
+              </c:pt>
+              <c:pt idx="13">
+                <c:v>Nov 25</c:v>
+              </c:pt>
+              <c:pt idx="14">
+                <c:v>Dec 25</c:v>
+              </c:pt>
+              <c:pt idx="15">
+                <c:v>Jan 26</c:v>
+              </c:pt>
+              <c:pt idx="16">
+                <c:v>Feb 26</c:v>
+              </c:pt>
+              <c:pt idx="17">
+                <c:v>Mar 26</c:v>
+              </c:pt>
+              <c:pt idx="18">
+                <c:v>Apr 26</c:v>
+              </c:pt>
+            </c:strLit>
+          </c:cat>
+          <c:val>
+            <c:numLit>
+              <c:formatCode>General</c:formatCode>
+              <c:ptCount val="19"/>
+              <c:pt idx="0">
+                <c:v>13.72</c:v>
+              </c:pt>
+              <c:pt idx="1">
+                <c:v>13.89</c:v>
+              </c:pt>
+              <c:pt idx="2">
+                <c:v>13.95</c:v>
+              </c:pt>
+              <c:pt idx="3">
+                <c:v>14.26</c:v>
+              </c:pt>
+              <c:pt idx="4">
+                <c:v>13.5</c:v>
+              </c:pt>
+              <c:pt idx="5">
+                <c:v>14.68</c:v>
+              </c:pt>
+              <c:pt idx="6">
+                <c:v>14.4</c:v>
+              </c:pt>
+              <c:pt idx="7">
+                <c:v>14.21</c:v>
+              </c:pt>
+              <c:pt idx="8">
+                <c:v>13.68</c:v>
+              </c:pt>
+              <c:pt idx="9">
+                <c:v>14.16</c:v>
+              </c:pt>
+              <c:pt idx="10">
+                <c:v>13.82</c:v>
+              </c:pt>
+              <c:pt idx="11">
+                <c:v>14.16</c:v>
+              </c:pt>
+              <c:pt idx="12">
+                <c:v>14.16</c:v>
+              </c:pt>
+              <c:pt idx="13">
+                <c:v>14</c:v>
+              </c:pt>
+              <c:pt idx="14">
+                <c:v>14.48</c:v>
+              </c:pt>
+              <c:pt idx="15">
+                <c:v>14.19</c:v>
+              </c:pt>
+              <c:pt idx="16">
+                <c:v>14.25</c:v>
+              </c:pt>
+              <c:pt idx="17">
+                <c:v>13.34</c:v>
+              </c:pt>
+              <c:pt idx="18">
+                <c:v>14.79</c:v>
+              </c:pt>
+            </c:numLit>
+          </c:val>
+          <c:smooth val="1"/>
+          <c:extLst>
+            <c:ext xmlns:c16="http://schemas.microsoft.com/office/drawing/2014/chart" uri="{C3380CC4-5D6E-409C-BE32-E72D297353CC}">
+              <c16:uniqueId val="{00000000-DAA6-45CE-B2EE-CEA85B71E990}"/>
+            </c:ext>
+          </c:extLst>
+        </c:ser>
+        <c:ser>
+          <c:idx val="1"/>
+          <c:order val="1"/>
+          <c:tx>
+            <c:v>Comparable PCL clients (no CRV)</c:v>
+          </c:tx>
+          <c:spPr>
+            <a:ln w="28575">
+              <a:solidFill>
+                <a:srgbClr val="1F4E79"/>
+              </a:solidFill>
+            </a:ln>
+          </c:spPr>
+          <c:marker>
+            <c:symbol val="circle"/>
+            <c:size val="5"/>
+            <c:spPr>
+              <a:solidFill>
+                <a:srgbClr val="1F4E79"/>
+              </a:solidFill>
+              <a:ln>
+                <a:solidFill>
+                  <a:srgbClr val="1F4E79"/>
+                </a:solidFill>
+              </a:ln>
+            </c:spPr>
+          </c:marker>
+          <c:cat>
+            <c:strLit>
+              <c:ptCount val="19"/>
+              <c:pt idx="0">
+                <c:v>Oct 24</c:v>
+              </c:pt>
+              <c:pt idx="1">
+                <c:v>Nov 24</c:v>
+              </c:pt>
+              <c:pt idx="2">
+                <c:v>Dec 24</c:v>
+              </c:pt>
+              <c:pt idx="3">
+                <c:v>Jan 25</c:v>
+              </c:pt>
+              <c:pt idx="4">
+                <c:v>Feb 25</c:v>
+              </c:pt>
+              <c:pt idx="5">
+                <c:v>Mar 25</c:v>
+              </c:pt>
+              <c:pt idx="6">
+                <c:v>Apr 25</c:v>
+              </c:pt>
+              <c:pt idx="7">
+                <c:v>May 25</c:v>
+              </c:pt>
+              <c:pt idx="8">
+                <c:v>Jun 25</c:v>
+              </c:pt>
+              <c:pt idx="9">
+                <c:v>Jul 25</c:v>
+              </c:pt>
+              <c:pt idx="10">
+                <c:v>Aug 25</c:v>
+              </c:pt>
+              <c:pt idx="11">
+                <c:v>Sep 25</c:v>
+              </c:pt>
+              <c:pt idx="12">
+                <c:v>Oct 25</c:v>
+              </c:pt>
+              <c:pt idx="13">
+                <c:v>Nov 25</c:v>
+              </c:pt>
+              <c:pt idx="14">
+                <c:v>Dec 25</c:v>
+              </c:pt>
+              <c:pt idx="15">
+                <c:v>Jan 26</c:v>
+              </c:pt>
+              <c:pt idx="16">
+                <c:v>Feb 26</c:v>
+              </c:pt>
+              <c:pt idx="17">
+                <c:v>Mar 26</c:v>
+              </c:pt>
+              <c:pt idx="18">
+                <c:v>Apr 26</c:v>
+              </c:pt>
+            </c:strLit>
+          </c:cat>
+          <c:val>
+            <c:numLit>
+              <c:formatCode>General</c:formatCode>
+              <c:ptCount val="19"/>
+              <c:pt idx="0">
+                <c:v>14.77</c:v>
+              </c:pt>
+              <c:pt idx="1">
+                <c:v>15.27</c:v>
+              </c:pt>
+              <c:pt idx="2">
+                <c:v>15.44</c:v>
+              </c:pt>
+              <c:pt idx="3">
+                <c:v>15.15</c:v>
+              </c:pt>
+              <c:pt idx="4">
+                <c:v>14.39</c:v>
+              </c:pt>
+              <c:pt idx="5">
+                <c:v>15.38</c:v>
+              </c:pt>
+              <c:pt idx="6">
+                <c:v>15.64</c:v>
+              </c:pt>
+              <c:pt idx="7">
+                <c:v>15.13</c:v>
+              </c:pt>
+              <c:pt idx="8">
+                <c:v>15.4</c:v>
+              </c:pt>
+              <c:pt idx="9">
+                <c:v>14.92</c:v>
+              </c:pt>
+              <c:pt idx="10">
+                <c:v>14.41</c:v>
+              </c:pt>
+              <c:pt idx="11">
+                <c:v>14.71</c:v>
+              </c:pt>
+              <c:pt idx="12">
+                <c:v>14.72</c:v>
+              </c:pt>
+              <c:pt idx="13">
+                <c:v>14.67</c:v>
+              </c:pt>
+              <c:pt idx="14">
+                <c:v>15.42</c:v>
+              </c:pt>
+              <c:pt idx="15">
+                <c:v>14.86</c:v>
+              </c:pt>
+              <c:pt idx="16">
+                <c:v>14.84</c:v>
+              </c:pt>
+              <c:pt idx="17">
+                <c:v>14.63</c:v>
+              </c:pt>
+              <c:pt idx="18">
+                <c:v>15.93</c:v>
+              </c:pt>
+            </c:numLit>
+          </c:val>
+          <c:smooth val="1"/>
+          <c:extLst>
+            <c:ext xmlns:c16="http://schemas.microsoft.com/office/drawing/2014/chart" uri="{C3380CC4-5D6E-409C-BE32-E72D297353CC}">
+              <c16:uniqueId val="{00000001-DAA6-45CE-B2EE-CEA85B71E990}"/>
             </c:ext>
           </c:extLst>
         </c:ser>
@@ -11808,7 +12826,13 @@
         <p:nvGraphicFramePr>
           <p:cNvPr id="701" name="PlotB"/>
           <p:cNvGraphicFramePr/>
-          <p:nvPr/>
+          <p:nvPr>
+            <p:extLst>
+              <p:ext uri="{D42A27DB-BD31-4B8C-83A1-F6EECF244321}">
+                <p14:modId xmlns:p14="http://schemas.microsoft.com/office/powerpoint/2010/main" val="379558161"/>
+              </p:ext>
+            </p:extLst>
+          </p:nvPr>
         </p:nvGraphicFramePr>
         <p:xfrm>
           <a:off x="6159500" y="838200"/>
@@ -12078,6 +13102,478 @@
     <p:extLst>
       <p:ext uri="{BB962C8B-B14F-4D97-AF65-F5344CB8AC3E}">
         <p14:creationId xmlns:p14="http://schemas.microsoft.com/office/powerpoint/2010/main" val="1959926795"/>
+      </p:ext>
+    </p:extLst>
+  </p:cSld>
+  <p:clrMapOvr>
+    <a:masterClrMapping/>
+  </p:clrMapOvr>
+</p:sld>
+</file>
+
+<file path=ppt/slides/slide7.xml><?xml version="1.0" encoding="utf-8"?>
+<p:sld xmlns:a="http://schemas.openxmlformats.org/drawingml/2006/main" xmlns:r="http://schemas.openxmlformats.org/officeDocument/2006/relationships" xmlns:p="http://schemas.openxmlformats.org/presentationml/2006/main">
+  <p:cSld>
+    <p:spTree>
+      <p:nvGrpSpPr>
+        <p:cNvPr id="1" name=""/>
+        <p:cNvGrpSpPr/>
+        <p:nvPr/>
+      </p:nvGrpSpPr>
+      <p:grpSpPr>
+        <a:xfrm>
+          <a:off x="0" y="0"/>
+          <a:ext cx="0" cy="0"/>
+          <a:chOff x="0" y="0"/>
+          <a:chExt cx="0" cy="0"/>
+        </a:xfrm>
+      </p:grpSpPr>
+      <p:sp>
+        <p:nvSpPr>
+          <p:cNvPr id="801" name="GapShade"/>
+          <p:cNvSpPr/>
+          <p:nvPr/>
+        </p:nvSpPr>
+        <p:spPr>
+          <a:xfrm>
+            <a:off x="3657600" y="2989631"/>
+            <a:ext cx="4511040" cy="1223620"/>
+          </a:xfrm>
+          <a:custGeom>
+            <a:avLst/>
+            <a:gdLst/>
+            <a:ahLst/>
+            <a:cxnLst/>
+            <a:rect l="0" t="0" r="0" b="0"/>
+            <a:pathLst>
+              <a:path w="4511040" h="1223620">
+                <a:moveTo>
+                  <a:pt x="0" y="548030"/>
+                </a:moveTo>
+                <a:lnTo>
+                  <a:pt x="250613" y="311810"/>
+                </a:lnTo>
+                <a:lnTo>
+                  <a:pt x="501227" y="231496"/>
+                </a:lnTo>
+                <a:lnTo>
+                  <a:pt x="751840" y="368503"/>
+                </a:lnTo>
+                <a:lnTo>
+                  <a:pt x="1002453" y="727558"/>
+                </a:lnTo>
+                <a:lnTo>
+                  <a:pt x="1253067" y="259842"/>
+                </a:lnTo>
+                <a:lnTo>
+                  <a:pt x="1503680" y="137008"/>
+                </a:lnTo>
+                <a:lnTo>
+                  <a:pt x="1754293" y="377952"/>
+                </a:lnTo>
+                <a:lnTo>
+                  <a:pt x="2004907" y="250393"/>
+                </a:lnTo>
+                <a:lnTo>
+                  <a:pt x="2255520" y="477164"/>
+                </a:lnTo>
+                <a:lnTo>
+                  <a:pt x="2506133" y="718109"/>
+                </a:lnTo>
+                <a:lnTo>
+                  <a:pt x="2756747" y="576377"/>
+                </a:lnTo>
+                <a:lnTo>
+                  <a:pt x="3007360" y="571652"/>
+                </a:lnTo>
+                <a:lnTo>
+                  <a:pt x="3257973" y="595274"/>
+                </a:lnTo>
+                <a:lnTo>
+                  <a:pt x="3508587" y="240944"/>
+                </a:lnTo>
+                <a:lnTo>
+                  <a:pt x="3759200" y="505511"/>
+                </a:lnTo>
+                <a:lnTo>
+                  <a:pt x="4009813" y="514960"/>
+                </a:lnTo>
+                <a:lnTo>
+                  <a:pt x="4260427" y="614172"/>
+                </a:lnTo>
+                <a:lnTo>
+                  <a:pt x="4511040" y="0"/>
+                </a:lnTo>
+                <a:lnTo>
+                  <a:pt x="4511040" y="538582"/>
+                </a:lnTo>
+                <a:lnTo>
+                  <a:pt x="4260427" y="1223620"/>
+                </a:lnTo>
+                <a:lnTo>
+                  <a:pt x="4009813" y="793699"/>
+                </a:lnTo>
+                <a:lnTo>
+                  <a:pt x="3759200" y="822046"/>
+                </a:lnTo>
+                <a:lnTo>
+                  <a:pt x="3508587" y="685038"/>
+                </a:lnTo>
+                <a:lnTo>
+                  <a:pt x="3257973" y="911809"/>
+                </a:lnTo>
+                <a:lnTo>
+                  <a:pt x="3007360" y="836219"/>
+                </a:lnTo>
+                <a:lnTo>
+                  <a:pt x="2756747" y="836219"/>
+                </a:lnTo>
+                <a:lnTo>
+                  <a:pt x="2506133" y="996848"/>
+                </a:lnTo>
+                <a:lnTo>
+                  <a:pt x="2255520" y="836219"/>
+                </a:lnTo>
+                <a:lnTo>
+                  <a:pt x="2004907" y="1062990"/>
+                </a:lnTo>
+                <a:lnTo>
+                  <a:pt x="1754293" y="812597"/>
+                </a:lnTo>
+                <a:lnTo>
+                  <a:pt x="1503680" y="722833"/>
+                </a:lnTo>
+                <a:lnTo>
+                  <a:pt x="1253067" y="590550"/>
+                </a:lnTo>
+                <a:lnTo>
+                  <a:pt x="1002453" y="1148029"/>
+                </a:lnTo>
+                <a:lnTo>
+                  <a:pt x="751840" y="788975"/>
+                </a:lnTo>
+                <a:lnTo>
+                  <a:pt x="501227" y="935431"/>
+                </a:lnTo>
+                <a:lnTo>
+                  <a:pt x="250613" y="963778"/>
+                </a:lnTo>
+                <a:lnTo>
+                  <a:pt x="0" y="1044092"/>
+                </a:lnTo>
+                <a:close/>
+              </a:path>
+            </a:pathLst>
+          </a:custGeom>
+          <a:solidFill>
+            <a:srgbClr val="C2410C">
+              <a:alpha val="22000"/>
+            </a:srgbClr>
+          </a:solidFill>
+          <a:ln>
+            <a:noFill/>
+          </a:ln>
+        </p:spPr>
+        <p:txBody>
+          <a:bodyPr/>
+          <a:lstStyle/>
+          <a:p>
+            <a:endParaRPr/>
+          </a:p>
+        </p:txBody>
+      </p:sp>
+      <p:graphicFrame>
+        <p:nvGraphicFramePr>
+          <p:cNvPr id="800" name="PlotB_clean"/>
+          <p:cNvGraphicFramePr/>
+          <p:nvPr/>
+        </p:nvGraphicFramePr>
+        <p:xfrm>
+          <a:off x="3048000" y="838200"/>
+          <a:ext cx="6096000" cy="5334000"/>
+        </p:xfrm>
+        <a:graphic>
+          <a:graphicData uri="http://schemas.openxmlformats.org/drawingml/2006/chart">
+            <c:chart xmlns:c="http://schemas.openxmlformats.org/drawingml/2006/chart" xmlns:r="http://schemas.openxmlformats.org/officeDocument/2006/relationships" r:id="rId2"/>
+          </a:graphicData>
+        </a:graphic>
+      </p:graphicFrame>
+    </p:spTree>
+    <p:extLst>
+      <p:ext uri="{BB962C8B-B14F-4D97-AF65-F5344CB8AC3E}">
+        <p14:creationId xmlns:p14="http://schemas.microsoft.com/office/powerpoint/2010/main" val="3959438915"/>
+      </p:ext>
+    </p:extLst>
+  </p:cSld>
+  <p:clrMapOvr>
+    <a:masterClrMapping/>
+  </p:clrMapOvr>
+</p:sld>
+</file>
+
+<file path=ppt/slides/slide8.xml><?xml version="1.0" encoding="utf-8"?>
+<p:sld xmlns:a="http://schemas.openxmlformats.org/drawingml/2006/main" xmlns:r="http://schemas.openxmlformats.org/officeDocument/2006/relationships" xmlns:p="http://schemas.openxmlformats.org/presentationml/2006/main">
+  <p:cSld>
+    <p:spTree>
+      <p:nvGrpSpPr>
+        <p:cNvPr id="1" name=""/>
+        <p:cNvGrpSpPr/>
+        <p:nvPr/>
+      </p:nvGrpSpPr>
+      <p:grpSpPr>
+        <a:xfrm>
+          <a:off x="0" y="0"/>
+          <a:ext cx="0" cy="0"/>
+          <a:chOff x="0" y="0"/>
+          <a:chExt cx="0" cy="0"/>
+        </a:xfrm>
+      </p:grpSpPr>
+      <p:sp>
+        <p:nvSpPr>
+          <p:cNvPr id="901" name="GapShadeSmooth"/>
+          <p:cNvSpPr/>
+          <p:nvPr/>
+        </p:nvSpPr>
+        <p:spPr>
+          <a:xfrm>
+            <a:off x="3657600" y="2989631"/>
+            <a:ext cx="4511040" cy="1266139"/>
+          </a:xfrm>
+          <a:custGeom>
+            <a:avLst/>
+            <a:gdLst/>
+            <a:ahLst/>
+            <a:cxnLst/>
+            <a:rect l="0" t="0" r="0" b="0"/>
+            <a:pathLst>
+              <a:path w="4511040" h="1266139">
+                <a:moveTo>
+                  <a:pt x="0" y="548030"/>
+                </a:moveTo>
+                <a:cubicBezTo>
+                  <a:pt x="41769" y="508660"/>
+                  <a:pt x="167076" y="364566"/>
+                  <a:pt x="250613" y="311810"/>
+                </a:cubicBezTo>
+                <a:cubicBezTo>
+                  <a:pt x="334151" y="259055"/>
+                  <a:pt x="417689" y="222047"/>
+                  <a:pt x="501227" y="231496"/>
+                </a:cubicBezTo>
+                <a:cubicBezTo>
+                  <a:pt x="584764" y="240944"/>
+                  <a:pt x="668302" y="285826"/>
+                  <a:pt x="751840" y="368503"/>
+                </a:cubicBezTo>
+                <a:cubicBezTo>
+                  <a:pt x="835378" y="451180"/>
+                  <a:pt x="918916" y="745668"/>
+                  <a:pt x="1002453" y="727558"/>
+                </a:cubicBezTo>
+                <a:cubicBezTo>
+                  <a:pt x="1085991" y="709447"/>
+                  <a:pt x="1169529" y="358267"/>
+                  <a:pt x="1253067" y="259842"/>
+                </a:cubicBezTo>
+                <a:cubicBezTo>
+                  <a:pt x="1336604" y="161417"/>
+                  <a:pt x="1420142" y="117323"/>
+                  <a:pt x="1503680" y="137008"/>
+                </a:cubicBezTo>
+                <a:cubicBezTo>
+                  <a:pt x="1587218" y="156693"/>
+                  <a:pt x="1670756" y="359054"/>
+                  <a:pt x="1754293" y="377952"/>
+                </a:cubicBezTo>
+                <a:cubicBezTo>
+                  <a:pt x="1837831" y="396850"/>
+                  <a:pt x="1921369" y="233858"/>
+                  <a:pt x="2004907" y="250393"/>
+                </a:cubicBezTo>
+                <a:cubicBezTo>
+                  <a:pt x="2088444" y="266929"/>
+                  <a:pt x="2171982" y="399212"/>
+                  <a:pt x="2255520" y="477164"/>
+                </a:cubicBezTo>
+                <a:cubicBezTo>
+                  <a:pt x="2339058" y="555117"/>
+                  <a:pt x="2422596" y="701573"/>
+                  <a:pt x="2506133" y="718109"/>
+                </a:cubicBezTo>
+                <a:cubicBezTo>
+                  <a:pt x="2589671" y="734644"/>
+                  <a:pt x="2673209" y="600786"/>
+                  <a:pt x="2756747" y="576377"/>
+                </a:cubicBezTo>
+                <a:cubicBezTo>
+                  <a:pt x="2840284" y="551967"/>
+                  <a:pt x="2923822" y="568503"/>
+                  <a:pt x="3007360" y="571652"/>
+                </a:cubicBezTo>
+                <a:cubicBezTo>
+                  <a:pt x="3090898" y="574802"/>
+                  <a:pt x="3174436" y="650392"/>
+                  <a:pt x="3257973" y="595274"/>
+                </a:cubicBezTo>
+                <a:cubicBezTo>
+                  <a:pt x="3341511" y="540156"/>
+                  <a:pt x="3425049" y="255905"/>
+                  <a:pt x="3508587" y="240944"/>
+                </a:cubicBezTo>
+                <a:cubicBezTo>
+                  <a:pt x="3592124" y="225984"/>
+                  <a:pt x="3675662" y="459842"/>
+                  <a:pt x="3759200" y="505511"/>
+                </a:cubicBezTo>
+                <a:cubicBezTo>
+                  <a:pt x="3842738" y="551180"/>
+                  <a:pt x="3926276" y="496849"/>
+                  <a:pt x="4009813" y="514960"/>
+                </a:cubicBezTo>
+                <a:cubicBezTo>
+                  <a:pt x="4093351" y="533070"/>
+                  <a:pt x="4176889" y="699999"/>
+                  <a:pt x="4260427" y="614172"/>
+                </a:cubicBezTo>
+                <a:cubicBezTo>
+                  <a:pt x="4343964" y="528345"/>
+                  <a:pt x="4469271" y="102362"/>
+                  <a:pt x="4511040" y="0"/>
+                </a:cubicBezTo>
+                <a:lnTo>
+                  <a:pt x="4511040" y="538582"/>
+                </a:lnTo>
+                <a:cubicBezTo>
+                  <a:pt x="4469271" y="652755"/>
+                  <a:pt x="4343964" y="1181100"/>
+                  <a:pt x="4260427" y="1223620"/>
+                </a:cubicBezTo>
+                <a:cubicBezTo>
+                  <a:pt x="4176889" y="1266139"/>
+                  <a:pt x="4093351" y="860628"/>
+                  <a:pt x="4009813" y="793699"/>
+                </a:cubicBezTo>
+                <a:cubicBezTo>
+                  <a:pt x="3926276" y="726770"/>
+                  <a:pt x="3842738" y="840156"/>
+                  <a:pt x="3759200" y="822046"/>
+                </a:cubicBezTo>
+                <a:cubicBezTo>
+                  <a:pt x="3675662" y="803935"/>
+                  <a:pt x="3592124" y="670077"/>
+                  <a:pt x="3508587" y="685038"/>
+                </a:cubicBezTo>
+                <a:cubicBezTo>
+                  <a:pt x="3425049" y="699999"/>
+                  <a:pt x="3341511" y="886612"/>
+                  <a:pt x="3257973" y="911809"/>
+                </a:cubicBezTo>
+                <a:cubicBezTo>
+                  <a:pt x="3174436" y="937006"/>
+                  <a:pt x="3090898" y="848817"/>
+                  <a:pt x="3007360" y="836219"/>
+                </a:cubicBezTo>
+                <a:cubicBezTo>
+                  <a:pt x="2923822" y="823620"/>
+                  <a:pt x="2840284" y="809447"/>
+                  <a:pt x="2756747" y="836219"/>
+                </a:cubicBezTo>
+                <a:cubicBezTo>
+                  <a:pt x="2673209" y="862990"/>
+                  <a:pt x="2589671" y="996848"/>
+                  <a:pt x="2506133" y="996848"/>
+                </a:cubicBezTo>
+                <a:cubicBezTo>
+                  <a:pt x="2422596" y="996848"/>
+                  <a:pt x="2339058" y="825195"/>
+                  <a:pt x="2255520" y="836219"/>
+                </a:cubicBezTo>
+                <a:cubicBezTo>
+                  <a:pt x="2171982" y="847242"/>
+                  <a:pt x="2088444" y="1066927"/>
+                  <a:pt x="2004907" y="1062990"/>
+                </a:cubicBezTo>
+                <a:cubicBezTo>
+                  <a:pt x="1921369" y="1059053"/>
+                  <a:pt x="1837831" y="869290"/>
+                  <a:pt x="1754293" y="812597"/>
+                </a:cubicBezTo>
+                <a:cubicBezTo>
+                  <a:pt x="1670756" y="755904"/>
+                  <a:pt x="1587218" y="759841"/>
+                  <a:pt x="1503680" y="722833"/>
+                </a:cubicBezTo>
+                <a:cubicBezTo>
+                  <a:pt x="1420142" y="685825"/>
+                  <a:pt x="1336604" y="519684"/>
+                  <a:pt x="1253067" y="590550"/>
+                </a:cubicBezTo>
+                <a:cubicBezTo>
+                  <a:pt x="1169529" y="661416"/>
+                  <a:pt x="1085991" y="1114958"/>
+                  <a:pt x="1002453" y="1148029"/>
+                </a:cubicBezTo>
+                <a:cubicBezTo>
+                  <a:pt x="918916" y="1181100"/>
+                  <a:pt x="835378" y="824408"/>
+                  <a:pt x="751840" y="788975"/>
+                </a:cubicBezTo>
+                <a:cubicBezTo>
+                  <a:pt x="668302" y="753542"/>
+                  <a:pt x="584764" y="906297"/>
+                  <a:pt x="501227" y="935431"/>
+                </a:cubicBezTo>
+                <a:cubicBezTo>
+                  <a:pt x="417689" y="964565"/>
+                  <a:pt x="334151" y="945667"/>
+                  <a:pt x="250613" y="963778"/>
+                </a:cubicBezTo>
+                <a:cubicBezTo>
+                  <a:pt x="167076" y="981888"/>
+                  <a:pt x="41769" y="1030707"/>
+                  <a:pt x="0" y="1044092"/>
+                </a:cubicBezTo>
+                <a:close/>
+              </a:path>
+            </a:pathLst>
+          </a:custGeom>
+          <a:solidFill>
+            <a:srgbClr val="C2410C">
+              <a:alpha val="22000"/>
+            </a:srgbClr>
+          </a:solidFill>
+          <a:ln>
+            <a:noFill/>
+          </a:ln>
+        </p:spPr>
+        <p:txBody>
+          <a:bodyPr/>
+          <a:lstStyle/>
+          <a:p>
+            <a:endParaRPr/>
+          </a:p>
+        </p:txBody>
+      </p:sp>
+      <p:graphicFrame>
+        <p:nvGraphicFramePr>
+          <p:cNvPr id="900" name="PlotB_smooth"/>
+          <p:cNvGraphicFramePr/>
+          <p:nvPr/>
+        </p:nvGraphicFramePr>
+        <p:xfrm>
+          <a:off x="3048000" y="838200"/>
+          <a:ext cx="6096000" cy="5334000"/>
+        </p:xfrm>
+        <a:graphic>
+          <a:graphicData uri="http://schemas.openxmlformats.org/drawingml/2006/chart">
+            <c:chart xmlns:c="http://schemas.openxmlformats.org/drawingml/2006/chart" xmlns:r="http://schemas.openxmlformats.org/officeDocument/2006/relationships" r:id="rId2"/>
+          </a:graphicData>
+        </a:graphic>
+      </p:graphicFrame>
+    </p:spTree>
+    <p:extLst>
+      <p:ext uri="{BB962C8B-B14F-4D97-AF65-F5344CB8AC3E}">
+        <p14:creationId xmlns:p14="http://schemas.microsoft.com/office/powerpoint/2010/main" val="1894102913"/>
       </p:ext>
     </p:extLst>
   </p:cSld>
@@ -12384,7 +13880,7 @@
 
 <file path=ppt/webextensions/taskpanes.xml><?xml version="1.0" encoding="utf-8"?>
 <wetp:taskpanes xmlns:wetp="http://schemas.microsoft.com/office/webextensions/taskpanes/2010/11">
-  <wetp:taskpane dockstate="right" visibility="0" width="525" row="0">
+  <wetp:taskpane dockstate="right" visibility="0" width="919" row="0">
     <wetp:webextensionref xmlns:r="http://schemas.openxmlformats.org/officeDocument/2006/relationships" r:id="rId1"/>
   </wetp:taskpane>
 </wetp:taskpanes>

</xml_diff>